<commit_message>
Apply FeDril branding at presentation boundary
</commit_message>
<xml_diff>
--- a/docs/marketing/gccs-phase-2-sales-deck.pptx
+++ b/docs/marketing/gccs-phase-2-sales-deck.pptx
@@ -2,120 +2,25 @@
 <file path=ppt/presentation.xml><?xml version="1.0" encoding="utf-8"?>
 <p:presentation xmlns:p="http://schemas.openxmlformats.org/presentationml/2006/main">
   <p:sldMasterIdLst>
-    <p:sldMasterId xmlns:r="http://schemas.openxmlformats.org/officeDocument/2006/relationships" id="2147483648" r:id="R1308b71faf724edc"/>
+    <p:sldMasterId xmlns:r="http://schemas.openxmlformats.org/officeDocument/2006/relationships" id="2147483648" r:id="Rf077844e1cd14193"/>
   </p:sldMasterIdLst>
   <p:notesMasterIdLst>
-    <p:notesMasterId xmlns:r="http://schemas.openxmlformats.org/officeDocument/2006/relationships" r:id="Rb472dca2391e41e9"/>
+    <p:notesMasterId xmlns:r="http://schemas.openxmlformats.org/officeDocument/2006/relationships" r:id="Rbf6408776bbf4d8e"/>
   </p:notesMasterIdLst>
   <p:sldIdLst>
-    <p:sldId xmlns:r="http://schemas.openxmlformats.org/officeDocument/2006/relationships" id="256" r:id="R8a463ea4dc9a411c"/>
-    <p:sldId xmlns:r="http://schemas.openxmlformats.org/officeDocument/2006/relationships" id="257" r:id="R464b05f3de934bf6"/>
-    <p:sldId xmlns:r="http://schemas.openxmlformats.org/officeDocument/2006/relationships" id="258" r:id="R8227534bfd2a4c3f"/>
-    <p:sldId xmlns:r="http://schemas.openxmlformats.org/officeDocument/2006/relationships" id="259" r:id="Ra56398efb6ff4110"/>
-    <p:sldId xmlns:r="http://schemas.openxmlformats.org/officeDocument/2006/relationships" id="260" r:id="R4d60125384154824"/>
-    <p:sldId xmlns:r="http://schemas.openxmlformats.org/officeDocument/2006/relationships" id="261" r:id="R1f631f5008a74232"/>
-    <p:sldId xmlns:r="http://schemas.openxmlformats.org/officeDocument/2006/relationships" id="262" r:id="R561c0d76bc1d45c0"/>
-    <p:sldId xmlns:r="http://schemas.openxmlformats.org/officeDocument/2006/relationships" id="263" r:id="R16868245161c49f7"/>
-    <p:sldId xmlns:r="http://schemas.openxmlformats.org/officeDocument/2006/relationships" id="264" r:id="Rc9a093a27bee4b37"/>
-    <p:sldId xmlns:r="http://schemas.openxmlformats.org/officeDocument/2006/relationships" id="265" r:id="R790f47c08a204744"/>
+    <p:sldId xmlns:r="http://schemas.openxmlformats.org/officeDocument/2006/relationships" id="256" r:id="R326051b362df4a50"/>
+    <p:sldId xmlns:r="http://schemas.openxmlformats.org/officeDocument/2006/relationships" id="257" r:id="Rfd900c6a904e40d8"/>
+    <p:sldId xmlns:r="http://schemas.openxmlformats.org/officeDocument/2006/relationships" id="258" r:id="R1d83d251ddd9440a"/>
+    <p:sldId xmlns:r="http://schemas.openxmlformats.org/officeDocument/2006/relationships" id="259" r:id="R3c138ceeb35c4cc4"/>
+    <p:sldId xmlns:r="http://schemas.openxmlformats.org/officeDocument/2006/relationships" id="260" r:id="R539d92ebe38b4bc1"/>
+    <p:sldId xmlns:r="http://schemas.openxmlformats.org/officeDocument/2006/relationships" id="261" r:id="Rc774c0b1edc84f22"/>
+    <p:sldId xmlns:r="http://schemas.openxmlformats.org/officeDocument/2006/relationships" id="262" r:id="R3d7bc93db6d24af3"/>
+    <p:sldId xmlns:r="http://schemas.openxmlformats.org/officeDocument/2006/relationships" id="263" r:id="R0aecff544634456e"/>
+    <p:sldId xmlns:r="http://schemas.openxmlformats.org/officeDocument/2006/relationships" id="264" r:id="Rb33851a30ca34c9c"/>
+    <p:sldId xmlns:r="http://schemas.openxmlformats.org/officeDocument/2006/relationships" id="265" r:id="Rf1ec987f1fd94799"/>
   </p:sldIdLst>
   <p:sldSz cx="12191695" cy="6858000"/>
   <p:notesSz cx="6858000" cy="9144000"/>
-  <p:defaultTextStyle>
-    <a:defPPr xmlns:a="http://schemas.openxmlformats.org/drawingml/2006/main">
-      <a:defRPr lang="en-US"/>
-    </a:defPPr>
-    <a:lvl1pPr xmlns:a="http://schemas.openxmlformats.org/drawingml/2006/main" marL="0" indent="0" algn="l" defTabSz="914400">
-      <a:defRPr sz="1800" kern="1200">
-        <a:solidFill>
-          <a:schemeClr val="tx1"/>
-        </a:solidFill>
-        <a:latin typeface="+mn-lt"/>
-        <a:ea typeface="+mn-ea"/>
-        <a:cs typeface="+mn-cs"/>
-      </a:defRPr>
-    </a:lvl1pPr>
-    <a:lvl2pPr xmlns:a="http://schemas.openxmlformats.org/drawingml/2006/main" marL="457200" indent="0" algn="l" defTabSz="914400">
-      <a:defRPr sz="1800" kern="1200">
-        <a:solidFill>
-          <a:schemeClr val="tx1"/>
-        </a:solidFill>
-        <a:latin typeface="+mn-lt"/>
-        <a:ea typeface="+mn-ea"/>
-        <a:cs typeface="+mn-cs"/>
-      </a:defRPr>
-    </a:lvl2pPr>
-    <a:lvl3pPr xmlns:a="http://schemas.openxmlformats.org/drawingml/2006/main" marL="914400" indent="0" algn="l" defTabSz="914400">
-      <a:defRPr sz="1800" kern="1200">
-        <a:solidFill>
-          <a:schemeClr val="tx1"/>
-        </a:solidFill>
-        <a:latin typeface="+mn-lt"/>
-        <a:ea typeface="+mn-ea"/>
-        <a:cs typeface="+mn-cs"/>
-      </a:defRPr>
-    </a:lvl3pPr>
-    <a:lvl4pPr xmlns:a="http://schemas.openxmlformats.org/drawingml/2006/main" marL="1371600" indent="0" algn="l" defTabSz="914400">
-      <a:defRPr sz="1800" kern="1200">
-        <a:solidFill>
-          <a:schemeClr val="tx1"/>
-        </a:solidFill>
-        <a:latin typeface="+mn-lt"/>
-        <a:ea typeface="+mn-ea"/>
-        <a:cs typeface="+mn-cs"/>
-      </a:defRPr>
-    </a:lvl4pPr>
-    <a:lvl5pPr xmlns:a="http://schemas.openxmlformats.org/drawingml/2006/main" marL="1828800" indent="0" algn="l" defTabSz="914400">
-      <a:defRPr sz="1800" kern="1200">
-        <a:solidFill>
-          <a:schemeClr val="tx1"/>
-        </a:solidFill>
-        <a:latin typeface="+mn-lt"/>
-        <a:ea typeface="+mn-ea"/>
-        <a:cs typeface="+mn-cs"/>
-      </a:defRPr>
-    </a:lvl5pPr>
-    <a:lvl6pPr xmlns:a="http://schemas.openxmlformats.org/drawingml/2006/main" marL="2286000" indent="0" algn="l" defTabSz="914400">
-      <a:defRPr sz="1800" kern="1200">
-        <a:solidFill>
-          <a:schemeClr val="tx1"/>
-        </a:solidFill>
-        <a:latin typeface="+mn-lt"/>
-        <a:ea typeface="+mn-ea"/>
-        <a:cs typeface="+mn-cs"/>
-      </a:defRPr>
-    </a:lvl6pPr>
-    <a:lvl7pPr xmlns:a="http://schemas.openxmlformats.org/drawingml/2006/main" marL="2743200" indent="0" algn="l" defTabSz="914400">
-      <a:defRPr sz="1800" kern="1200">
-        <a:solidFill>
-          <a:schemeClr val="tx1"/>
-        </a:solidFill>
-        <a:latin typeface="+mn-lt"/>
-        <a:ea typeface="+mn-ea"/>
-        <a:cs typeface="+mn-cs"/>
-      </a:defRPr>
-    </a:lvl7pPr>
-    <a:lvl8pPr xmlns:a="http://schemas.openxmlformats.org/drawingml/2006/main" marL="3200400" indent="0" algn="l" defTabSz="914400">
-      <a:defRPr sz="1800" kern="1200">
-        <a:solidFill>
-          <a:schemeClr val="tx1"/>
-        </a:solidFill>
-        <a:latin typeface="+mn-lt"/>
-        <a:ea typeface="+mn-ea"/>
-        <a:cs typeface="+mn-cs"/>
-      </a:defRPr>
-    </a:lvl8pPr>
-    <a:lvl9pPr xmlns:a="http://schemas.openxmlformats.org/drawingml/2006/main" marL="3657600" indent="0" algn="l" defTabSz="914400">
-      <a:defRPr sz="1800" kern="1200">
-        <a:solidFill>
-          <a:schemeClr val="tx1"/>
-        </a:solidFill>
-        <a:latin typeface="+mn-lt"/>
-        <a:ea typeface="+mn-ea"/>
-        <a:cs typeface="+mn-cs"/>
-      </a:defRPr>
-    </a:lvl9pPr>
-  </p:defaultTextStyle>
 </p:presentation>
 </file>
 
@@ -4115,17 +4020,17 @@
   </p:cSld>
   <p:clrMap bg1="lt1" tx1="dk1" bg2="lt2" tx2="dk2" accent1="accent1" accent2="accent2" accent3="accent3" accent4="accent4" accent5="accent5" accent6="accent6" hlink="hlink" folHlink="folHlink"/>
   <p:sldLayoutIdLst>
-    <p:sldLayoutId xmlns:r="http://schemas.openxmlformats.org/officeDocument/2006/relationships" id="2147483649" r:id="R36944445cc7349f5"/>
-    <p:sldLayoutId xmlns:r="http://schemas.openxmlformats.org/officeDocument/2006/relationships" id="2147483650" r:id="R506b426a292041ab"/>
-    <p:sldLayoutId xmlns:r="http://schemas.openxmlformats.org/officeDocument/2006/relationships" id="2147483651" r:id="Rfab68cc39f004861"/>
-    <p:sldLayoutId xmlns:r="http://schemas.openxmlformats.org/officeDocument/2006/relationships" id="2147483652" r:id="R643f477a9632452a"/>
-    <p:sldLayoutId xmlns:r="http://schemas.openxmlformats.org/officeDocument/2006/relationships" id="2147483653" r:id="R1b697248aabe4956"/>
-    <p:sldLayoutId xmlns:r="http://schemas.openxmlformats.org/officeDocument/2006/relationships" id="2147483654" r:id="Rec3ae36feede432c"/>
-    <p:sldLayoutId xmlns:r="http://schemas.openxmlformats.org/officeDocument/2006/relationships" id="2147483655" r:id="R7e58fed0066141d7"/>
-    <p:sldLayoutId xmlns:r="http://schemas.openxmlformats.org/officeDocument/2006/relationships" id="2147483656" r:id="Rf22ac7904d0448ed"/>
-    <p:sldLayoutId xmlns:r="http://schemas.openxmlformats.org/officeDocument/2006/relationships" id="2147483657" r:id="Rab94ac63e91f4859"/>
-    <p:sldLayoutId xmlns:r="http://schemas.openxmlformats.org/officeDocument/2006/relationships" id="2147483658" r:id="Rbde6b661a1db481c"/>
-    <p:sldLayoutId xmlns:r="http://schemas.openxmlformats.org/officeDocument/2006/relationships" id="2147483659" r:id="Redf6b77063014ae1"/>
+    <p:sldLayoutId xmlns:r="http://schemas.openxmlformats.org/officeDocument/2006/relationships" id="2147483649" r:id="R0fed0646cf2445e3"/>
+    <p:sldLayoutId xmlns:r="http://schemas.openxmlformats.org/officeDocument/2006/relationships" id="2147483650" r:id="R94c78521eb2244c2"/>
+    <p:sldLayoutId xmlns:r="http://schemas.openxmlformats.org/officeDocument/2006/relationships" id="2147483651" r:id="R7a0216cb8f0b4f8e"/>
+    <p:sldLayoutId xmlns:r="http://schemas.openxmlformats.org/officeDocument/2006/relationships" id="2147483652" r:id="R72e3b31f41784ece"/>
+    <p:sldLayoutId xmlns:r="http://schemas.openxmlformats.org/officeDocument/2006/relationships" id="2147483653" r:id="R9b0462f1f2aa4eb7"/>
+    <p:sldLayoutId xmlns:r="http://schemas.openxmlformats.org/officeDocument/2006/relationships" id="2147483654" r:id="R653c16bf167f45d3"/>
+    <p:sldLayoutId xmlns:r="http://schemas.openxmlformats.org/officeDocument/2006/relationships" id="2147483655" r:id="Rdf1e4de28f0445b4"/>
+    <p:sldLayoutId xmlns:r="http://schemas.openxmlformats.org/officeDocument/2006/relationships" id="2147483656" r:id="Rfd59776ab59f4473"/>
+    <p:sldLayoutId xmlns:r="http://schemas.openxmlformats.org/officeDocument/2006/relationships" id="2147483657" r:id="Ree703b4d85ff496d"/>
+    <p:sldLayoutId xmlns:r="http://schemas.openxmlformats.org/officeDocument/2006/relationships" id="2147483658" r:id="Raea3d09f9b814f96"/>
+    <p:sldLayoutId xmlns:r="http://schemas.openxmlformats.org/officeDocument/2006/relationships" id="2147483659" r:id="Reec2ed17405e4d68"/>
   </p:sldLayoutIdLst>
   <p:txStyles>
     <p:titleStyle>
@@ -4757,7 +4662,7 @@
         <p:spPr>
           <a:xfrm xmlns:a="http://schemas.openxmlformats.org/drawingml/2006/main">
             <a:off x="1170432" y="1627632"/>
-            <a:ext cx="1444752" cy="365760"/>
+            <a:ext cx="1444752" cy="417576"/>
           </a:xfrm>
           <a:prstGeom xmlns:a="http://schemas.openxmlformats.org/drawingml/2006/main" prst="rect">
             <a:avLst/>
@@ -4782,7 +4687,7 @@
               </a:defRPr>
             </a:pPr>
             <a:r>
-              <a:t>GCCS</a:t>
+              <a:t>FeDril</a:t>
             </a:r>
           </a:p>
         </p:txBody>
@@ -4829,7 +4734,10 @@
               </a:defRPr>
             </a:pPr>
             <a:r>
-              <a:t>GCCS | NO-CUI COMPLIANCE MANAGEMENT MVP</a:t>
+              <a:t>FeDril</a:t>
+            </a:r>
+            <a:r>
+              <a:t> | NO-CUI COMPLIANCE MANAGEMENT MVP</a:t>
             </a:r>
           </a:p>
         </p:txBody>
@@ -5072,7 +4980,10 @@
               </a:defRPr>
             </a:pPr>
             <a:r>
-              <a:t>GCCS | No-CUI compliance management only</a:t>
+              <a:t>FeDril</a:t>
+            </a:r>
+            <a:r>
+              <a:t> | No-CUI compliance management only</a:t>
             </a:r>
           </a:p>
         </p:txBody>
@@ -5513,7 +5424,7 @@
         <p:spPr>
           <a:xfrm xmlns:a="http://schemas.openxmlformats.org/drawingml/2006/main">
             <a:off x="7498079" y="2212848"/>
-            <a:ext cx="3337560" cy="1143000"/>
+            <a:ext cx="3337560" cy="1408176"/>
           </a:xfrm>
           <a:prstGeom xmlns:a="http://schemas.openxmlformats.org/drawingml/2006/main" prst="rect">
             <a:avLst/>
@@ -5538,7 +5449,10 @@
               </a:defRPr>
             </a:pPr>
             <a:r>
-              <a:t>GCCS helps your team organize what applies, track who owns it, and produce readiness evidence without scattered spreadsheets.</a:t>
+              <a:t>FeDril</a:t>
+            </a:r>
+            <a:r>
+              <a:t> helps your team organize what applies, track who owns it, and produce readiness evidence without scattered spreadsheets.</a:t>
             </a:r>
           </a:p>
         </p:txBody>
@@ -5685,7 +5599,10 @@
               </a:defRPr>
             </a:pPr>
             <a:r>
-              <a:t>GCCS | No-CUI compliance management only</a:t>
+              <a:t>FeDril</a:t>
+            </a:r>
+            <a:r>
+              <a:t> | No-CUI compliance management only</a:t>
             </a:r>
           </a:p>
         </p:txBody>
@@ -6096,7 +6013,10 @@
               </a:defRPr>
             </a:pPr>
             <a:r>
-              <a:t>GCCS | No-CUI compliance management only</a:t>
+              <a:t>FeDril</a:t>
+            </a:r>
+            <a:r>
+              <a:t> | No-CUI compliance management only</a:t>
             </a:r>
           </a:p>
         </p:txBody>
@@ -6656,7 +6576,10 @@
               </a:defRPr>
             </a:pPr>
             <a:r>
-              <a:t>GCCS | No-CUI compliance management only</a:t>
+              <a:t>FeDril</a:t>
+            </a:r>
+            <a:r>
+              <a:t> | No-CUI compliance management only</a:t>
             </a:r>
           </a:p>
         </p:txBody>
@@ -6954,7 +6877,13 @@
               </a:defRPr>
             </a:pPr>
             <a:r>
-              <a:t>Track evidence metadata without using GCCS as a CUI repository.</a:t>
+              <a:t>Track evidence metadata without using </a:t>
+            </a:r>
+            <a:r>
+              <a:t>FeDril</a:t>
+            </a:r>
+            <a:r>
+              <a:t> as a CUI repository.</a:t>
             </a:r>
           </a:p>
           <a:p xmlns:a="http://schemas.openxmlformats.org/drawingml/2006/main">
@@ -7067,7 +6996,10 @@
               </a:defRPr>
             </a:pPr>
             <a:r>
-              <a:t>GCCS | No-CUI compliance management only</a:t>
+              <a:t>FeDril</a:t>
+            </a:r>
+            <a:r>
+              <a:t> | No-CUI compliance management only</a:t>
             </a:r>
           </a:p>
         </p:txBody>
@@ -8549,7 +8481,10 @@
               </a:defRPr>
             </a:pPr>
             <a:r>
-              <a:t>GCCS | No-CUI compliance management only</a:t>
+              <a:t>FeDril</a:t>
+            </a:r>
+            <a:r>
+              <a:t> | No-CUI compliance management only</a:t>
             </a:r>
           </a:p>
         </p:txBody>
@@ -9431,7 +9366,10 @@
               </a:defRPr>
             </a:pPr>
             <a:r>
-              <a:t>GCCS | No-CUI compliance management only</a:t>
+              <a:t>FeDril</a:t>
+            </a:r>
+            <a:r>
+              <a:t> | No-CUI compliance management only</a:t>
             </a:r>
           </a:p>
         </p:txBody>
@@ -9944,7 +9882,10 @@
               </a:defRPr>
             </a:pPr>
             <a:r>
-              <a:t>GCCS | No-CUI compliance management only</a:t>
+              <a:t>FeDril</a:t>
+            </a:r>
+            <a:r>
+              <a:t> | No-CUI compliance management only</a:t>
             </a:r>
           </a:p>
         </p:txBody>
@@ -10656,7 +10597,10 @@
               </a:defRPr>
             </a:pPr>
             <a:r>
-              <a:t>GCCS | No-CUI compliance management only</a:t>
+              <a:t>FeDril</a:t>
+            </a:r>
+            <a:r>
+              <a:t> | No-CUI compliance management only</a:t>
             </a:r>
           </a:p>
         </p:txBody>
@@ -11228,7 +11172,10 @@
               </a:defRPr>
             </a:pPr>
             <a:r>
-              <a:t>GCCS | No-CUI compliance management only</a:t>
+              <a:t>FeDril</a:t>
+            </a:r>
+            <a:r>
+              <a:t> | No-CUI compliance management only</a:t>
             </a:r>
           </a:p>
         </p:txBody>

</xml_diff>

<commit_message>
Apply FeDril branding at presentation boundary (#23)
Preserve internal GCCS identifiers while applying FeDril branding at the presentation boundary. Verified by CI and exact-commit staging deployment.
</commit_message>
<xml_diff>
--- a/docs/marketing/gccs-phase-2-sales-deck.pptx
+++ b/docs/marketing/gccs-phase-2-sales-deck.pptx
@@ -2,120 +2,25 @@
 <file path=ppt/presentation.xml><?xml version="1.0" encoding="utf-8"?>
 <p:presentation xmlns:p="http://schemas.openxmlformats.org/presentationml/2006/main">
   <p:sldMasterIdLst>
-    <p:sldMasterId xmlns:r="http://schemas.openxmlformats.org/officeDocument/2006/relationships" id="2147483648" r:id="R1308b71faf724edc"/>
+    <p:sldMasterId xmlns:r="http://schemas.openxmlformats.org/officeDocument/2006/relationships" id="2147483648" r:id="Rf077844e1cd14193"/>
   </p:sldMasterIdLst>
   <p:notesMasterIdLst>
-    <p:notesMasterId xmlns:r="http://schemas.openxmlformats.org/officeDocument/2006/relationships" r:id="Rb472dca2391e41e9"/>
+    <p:notesMasterId xmlns:r="http://schemas.openxmlformats.org/officeDocument/2006/relationships" r:id="Rbf6408776bbf4d8e"/>
   </p:notesMasterIdLst>
   <p:sldIdLst>
-    <p:sldId xmlns:r="http://schemas.openxmlformats.org/officeDocument/2006/relationships" id="256" r:id="R8a463ea4dc9a411c"/>
-    <p:sldId xmlns:r="http://schemas.openxmlformats.org/officeDocument/2006/relationships" id="257" r:id="R464b05f3de934bf6"/>
-    <p:sldId xmlns:r="http://schemas.openxmlformats.org/officeDocument/2006/relationships" id="258" r:id="R8227534bfd2a4c3f"/>
-    <p:sldId xmlns:r="http://schemas.openxmlformats.org/officeDocument/2006/relationships" id="259" r:id="Ra56398efb6ff4110"/>
-    <p:sldId xmlns:r="http://schemas.openxmlformats.org/officeDocument/2006/relationships" id="260" r:id="R4d60125384154824"/>
-    <p:sldId xmlns:r="http://schemas.openxmlformats.org/officeDocument/2006/relationships" id="261" r:id="R1f631f5008a74232"/>
-    <p:sldId xmlns:r="http://schemas.openxmlformats.org/officeDocument/2006/relationships" id="262" r:id="R561c0d76bc1d45c0"/>
-    <p:sldId xmlns:r="http://schemas.openxmlformats.org/officeDocument/2006/relationships" id="263" r:id="R16868245161c49f7"/>
-    <p:sldId xmlns:r="http://schemas.openxmlformats.org/officeDocument/2006/relationships" id="264" r:id="Rc9a093a27bee4b37"/>
-    <p:sldId xmlns:r="http://schemas.openxmlformats.org/officeDocument/2006/relationships" id="265" r:id="R790f47c08a204744"/>
+    <p:sldId xmlns:r="http://schemas.openxmlformats.org/officeDocument/2006/relationships" id="256" r:id="R326051b362df4a50"/>
+    <p:sldId xmlns:r="http://schemas.openxmlformats.org/officeDocument/2006/relationships" id="257" r:id="Rfd900c6a904e40d8"/>
+    <p:sldId xmlns:r="http://schemas.openxmlformats.org/officeDocument/2006/relationships" id="258" r:id="R1d83d251ddd9440a"/>
+    <p:sldId xmlns:r="http://schemas.openxmlformats.org/officeDocument/2006/relationships" id="259" r:id="R3c138ceeb35c4cc4"/>
+    <p:sldId xmlns:r="http://schemas.openxmlformats.org/officeDocument/2006/relationships" id="260" r:id="R539d92ebe38b4bc1"/>
+    <p:sldId xmlns:r="http://schemas.openxmlformats.org/officeDocument/2006/relationships" id="261" r:id="Rc774c0b1edc84f22"/>
+    <p:sldId xmlns:r="http://schemas.openxmlformats.org/officeDocument/2006/relationships" id="262" r:id="R3d7bc93db6d24af3"/>
+    <p:sldId xmlns:r="http://schemas.openxmlformats.org/officeDocument/2006/relationships" id="263" r:id="R0aecff544634456e"/>
+    <p:sldId xmlns:r="http://schemas.openxmlformats.org/officeDocument/2006/relationships" id="264" r:id="Rb33851a30ca34c9c"/>
+    <p:sldId xmlns:r="http://schemas.openxmlformats.org/officeDocument/2006/relationships" id="265" r:id="Rf1ec987f1fd94799"/>
   </p:sldIdLst>
   <p:sldSz cx="12191695" cy="6858000"/>
   <p:notesSz cx="6858000" cy="9144000"/>
-  <p:defaultTextStyle>
-    <a:defPPr xmlns:a="http://schemas.openxmlformats.org/drawingml/2006/main">
-      <a:defRPr lang="en-US"/>
-    </a:defPPr>
-    <a:lvl1pPr xmlns:a="http://schemas.openxmlformats.org/drawingml/2006/main" marL="0" indent="0" algn="l" defTabSz="914400">
-      <a:defRPr sz="1800" kern="1200">
-        <a:solidFill>
-          <a:schemeClr val="tx1"/>
-        </a:solidFill>
-        <a:latin typeface="+mn-lt"/>
-        <a:ea typeface="+mn-ea"/>
-        <a:cs typeface="+mn-cs"/>
-      </a:defRPr>
-    </a:lvl1pPr>
-    <a:lvl2pPr xmlns:a="http://schemas.openxmlformats.org/drawingml/2006/main" marL="457200" indent="0" algn="l" defTabSz="914400">
-      <a:defRPr sz="1800" kern="1200">
-        <a:solidFill>
-          <a:schemeClr val="tx1"/>
-        </a:solidFill>
-        <a:latin typeface="+mn-lt"/>
-        <a:ea typeface="+mn-ea"/>
-        <a:cs typeface="+mn-cs"/>
-      </a:defRPr>
-    </a:lvl2pPr>
-    <a:lvl3pPr xmlns:a="http://schemas.openxmlformats.org/drawingml/2006/main" marL="914400" indent="0" algn="l" defTabSz="914400">
-      <a:defRPr sz="1800" kern="1200">
-        <a:solidFill>
-          <a:schemeClr val="tx1"/>
-        </a:solidFill>
-        <a:latin typeface="+mn-lt"/>
-        <a:ea typeface="+mn-ea"/>
-        <a:cs typeface="+mn-cs"/>
-      </a:defRPr>
-    </a:lvl3pPr>
-    <a:lvl4pPr xmlns:a="http://schemas.openxmlformats.org/drawingml/2006/main" marL="1371600" indent="0" algn="l" defTabSz="914400">
-      <a:defRPr sz="1800" kern="1200">
-        <a:solidFill>
-          <a:schemeClr val="tx1"/>
-        </a:solidFill>
-        <a:latin typeface="+mn-lt"/>
-        <a:ea typeface="+mn-ea"/>
-        <a:cs typeface="+mn-cs"/>
-      </a:defRPr>
-    </a:lvl4pPr>
-    <a:lvl5pPr xmlns:a="http://schemas.openxmlformats.org/drawingml/2006/main" marL="1828800" indent="0" algn="l" defTabSz="914400">
-      <a:defRPr sz="1800" kern="1200">
-        <a:solidFill>
-          <a:schemeClr val="tx1"/>
-        </a:solidFill>
-        <a:latin typeface="+mn-lt"/>
-        <a:ea typeface="+mn-ea"/>
-        <a:cs typeface="+mn-cs"/>
-      </a:defRPr>
-    </a:lvl5pPr>
-    <a:lvl6pPr xmlns:a="http://schemas.openxmlformats.org/drawingml/2006/main" marL="2286000" indent="0" algn="l" defTabSz="914400">
-      <a:defRPr sz="1800" kern="1200">
-        <a:solidFill>
-          <a:schemeClr val="tx1"/>
-        </a:solidFill>
-        <a:latin typeface="+mn-lt"/>
-        <a:ea typeface="+mn-ea"/>
-        <a:cs typeface="+mn-cs"/>
-      </a:defRPr>
-    </a:lvl6pPr>
-    <a:lvl7pPr xmlns:a="http://schemas.openxmlformats.org/drawingml/2006/main" marL="2743200" indent="0" algn="l" defTabSz="914400">
-      <a:defRPr sz="1800" kern="1200">
-        <a:solidFill>
-          <a:schemeClr val="tx1"/>
-        </a:solidFill>
-        <a:latin typeface="+mn-lt"/>
-        <a:ea typeface="+mn-ea"/>
-        <a:cs typeface="+mn-cs"/>
-      </a:defRPr>
-    </a:lvl7pPr>
-    <a:lvl8pPr xmlns:a="http://schemas.openxmlformats.org/drawingml/2006/main" marL="3200400" indent="0" algn="l" defTabSz="914400">
-      <a:defRPr sz="1800" kern="1200">
-        <a:solidFill>
-          <a:schemeClr val="tx1"/>
-        </a:solidFill>
-        <a:latin typeface="+mn-lt"/>
-        <a:ea typeface="+mn-ea"/>
-        <a:cs typeface="+mn-cs"/>
-      </a:defRPr>
-    </a:lvl8pPr>
-    <a:lvl9pPr xmlns:a="http://schemas.openxmlformats.org/drawingml/2006/main" marL="3657600" indent="0" algn="l" defTabSz="914400">
-      <a:defRPr sz="1800" kern="1200">
-        <a:solidFill>
-          <a:schemeClr val="tx1"/>
-        </a:solidFill>
-        <a:latin typeface="+mn-lt"/>
-        <a:ea typeface="+mn-ea"/>
-        <a:cs typeface="+mn-cs"/>
-      </a:defRPr>
-    </a:lvl9pPr>
-  </p:defaultTextStyle>
 </p:presentation>
 </file>
 
@@ -4115,17 +4020,17 @@
   </p:cSld>
   <p:clrMap bg1="lt1" tx1="dk1" bg2="lt2" tx2="dk2" accent1="accent1" accent2="accent2" accent3="accent3" accent4="accent4" accent5="accent5" accent6="accent6" hlink="hlink" folHlink="folHlink"/>
   <p:sldLayoutIdLst>
-    <p:sldLayoutId xmlns:r="http://schemas.openxmlformats.org/officeDocument/2006/relationships" id="2147483649" r:id="R36944445cc7349f5"/>
-    <p:sldLayoutId xmlns:r="http://schemas.openxmlformats.org/officeDocument/2006/relationships" id="2147483650" r:id="R506b426a292041ab"/>
-    <p:sldLayoutId xmlns:r="http://schemas.openxmlformats.org/officeDocument/2006/relationships" id="2147483651" r:id="Rfab68cc39f004861"/>
-    <p:sldLayoutId xmlns:r="http://schemas.openxmlformats.org/officeDocument/2006/relationships" id="2147483652" r:id="R643f477a9632452a"/>
-    <p:sldLayoutId xmlns:r="http://schemas.openxmlformats.org/officeDocument/2006/relationships" id="2147483653" r:id="R1b697248aabe4956"/>
-    <p:sldLayoutId xmlns:r="http://schemas.openxmlformats.org/officeDocument/2006/relationships" id="2147483654" r:id="Rec3ae36feede432c"/>
-    <p:sldLayoutId xmlns:r="http://schemas.openxmlformats.org/officeDocument/2006/relationships" id="2147483655" r:id="R7e58fed0066141d7"/>
-    <p:sldLayoutId xmlns:r="http://schemas.openxmlformats.org/officeDocument/2006/relationships" id="2147483656" r:id="Rf22ac7904d0448ed"/>
-    <p:sldLayoutId xmlns:r="http://schemas.openxmlformats.org/officeDocument/2006/relationships" id="2147483657" r:id="Rab94ac63e91f4859"/>
-    <p:sldLayoutId xmlns:r="http://schemas.openxmlformats.org/officeDocument/2006/relationships" id="2147483658" r:id="Rbde6b661a1db481c"/>
-    <p:sldLayoutId xmlns:r="http://schemas.openxmlformats.org/officeDocument/2006/relationships" id="2147483659" r:id="Redf6b77063014ae1"/>
+    <p:sldLayoutId xmlns:r="http://schemas.openxmlformats.org/officeDocument/2006/relationships" id="2147483649" r:id="R0fed0646cf2445e3"/>
+    <p:sldLayoutId xmlns:r="http://schemas.openxmlformats.org/officeDocument/2006/relationships" id="2147483650" r:id="R94c78521eb2244c2"/>
+    <p:sldLayoutId xmlns:r="http://schemas.openxmlformats.org/officeDocument/2006/relationships" id="2147483651" r:id="R7a0216cb8f0b4f8e"/>
+    <p:sldLayoutId xmlns:r="http://schemas.openxmlformats.org/officeDocument/2006/relationships" id="2147483652" r:id="R72e3b31f41784ece"/>
+    <p:sldLayoutId xmlns:r="http://schemas.openxmlformats.org/officeDocument/2006/relationships" id="2147483653" r:id="R9b0462f1f2aa4eb7"/>
+    <p:sldLayoutId xmlns:r="http://schemas.openxmlformats.org/officeDocument/2006/relationships" id="2147483654" r:id="R653c16bf167f45d3"/>
+    <p:sldLayoutId xmlns:r="http://schemas.openxmlformats.org/officeDocument/2006/relationships" id="2147483655" r:id="Rdf1e4de28f0445b4"/>
+    <p:sldLayoutId xmlns:r="http://schemas.openxmlformats.org/officeDocument/2006/relationships" id="2147483656" r:id="Rfd59776ab59f4473"/>
+    <p:sldLayoutId xmlns:r="http://schemas.openxmlformats.org/officeDocument/2006/relationships" id="2147483657" r:id="Ree703b4d85ff496d"/>
+    <p:sldLayoutId xmlns:r="http://schemas.openxmlformats.org/officeDocument/2006/relationships" id="2147483658" r:id="Raea3d09f9b814f96"/>
+    <p:sldLayoutId xmlns:r="http://schemas.openxmlformats.org/officeDocument/2006/relationships" id="2147483659" r:id="Reec2ed17405e4d68"/>
   </p:sldLayoutIdLst>
   <p:txStyles>
     <p:titleStyle>
@@ -4757,7 +4662,7 @@
         <p:spPr>
           <a:xfrm xmlns:a="http://schemas.openxmlformats.org/drawingml/2006/main">
             <a:off x="1170432" y="1627632"/>
-            <a:ext cx="1444752" cy="365760"/>
+            <a:ext cx="1444752" cy="417576"/>
           </a:xfrm>
           <a:prstGeom xmlns:a="http://schemas.openxmlformats.org/drawingml/2006/main" prst="rect">
             <a:avLst/>
@@ -4782,7 +4687,7 @@
               </a:defRPr>
             </a:pPr>
             <a:r>
-              <a:t>GCCS</a:t>
+              <a:t>FeDril</a:t>
             </a:r>
           </a:p>
         </p:txBody>
@@ -4829,7 +4734,10 @@
               </a:defRPr>
             </a:pPr>
             <a:r>
-              <a:t>GCCS | NO-CUI COMPLIANCE MANAGEMENT MVP</a:t>
+              <a:t>FeDril</a:t>
+            </a:r>
+            <a:r>
+              <a:t> | NO-CUI COMPLIANCE MANAGEMENT MVP</a:t>
             </a:r>
           </a:p>
         </p:txBody>
@@ -5072,7 +4980,10 @@
               </a:defRPr>
             </a:pPr>
             <a:r>
-              <a:t>GCCS | No-CUI compliance management only</a:t>
+              <a:t>FeDril</a:t>
+            </a:r>
+            <a:r>
+              <a:t> | No-CUI compliance management only</a:t>
             </a:r>
           </a:p>
         </p:txBody>
@@ -5513,7 +5424,7 @@
         <p:spPr>
           <a:xfrm xmlns:a="http://schemas.openxmlformats.org/drawingml/2006/main">
             <a:off x="7498079" y="2212848"/>
-            <a:ext cx="3337560" cy="1143000"/>
+            <a:ext cx="3337560" cy="1408176"/>
           </a:xfrm>
           <a:prstGeom xmlns:a="http://schemas.openxmlformats.org/drawingml/2006/main" prst="rect">
             <a:avLst/>
@@ -5538,7 +5449,10 @@
               </a:defRPr>
             </a:pPr>
             <a:r>
-              <a:t>GCCS helps your team organize what applies, track who owns it, and produce readiness evidence without scattered spreadsheets.</a:t>
+              <a:t>FeDril</a:t>
+            </a:r>
+            <a:r>
+              <a:t> helps your team organize what applies, track who owns it, and produce readiness evidence without scattered spreadsheets.</a:t>
             </a:r>
           </a:p>
         </p:txBody>
@@ -5685,7 +5599,10 @@
               </a:defRPr>
             </a:pPr>
             <a:r>
-              <a:t>GCCS | No-CUI compliance management only</a:t>
+              <a:t>FeDril</a:t>
+            </a:r>
+            <a:r>
+              <a:t> | No-CUI compliance management only</a:t>
             </a:r>
           </a:p>
         </p:txBody>
@@ -6096,7 +6013,10 @@
               </a:defRPr>
             </a:pPr>
             <a:r>
-              <a:t>GCCS | No-CUI compliance management only</a:t>
+              <a:t>FeDril</a:t>
+            </a:r>
+            <a:r>
+              <a:t> | No-CUI compliance management only</a:t>
             </a:r>
           </a:p>
         </p:txBody>
@@ -6656,7 +6576,10 @@
               </a:defRPr>
             </a:pPr>
             <a:r>
-              <a:t>GCCS | No-CUI compliance management only</a:t>
+              <a:t>FeDril</a:t>
+            </a:r>
+            <a:r>
+              <a:t> | No-CUI compliance management only</a:t>
             </a:r>
           </a:p>
         </p:txBody>
@@ -6954,7 +6877,13 @@
               </a:defRPr>
             </a:pPr>
             <a:r>
-              <a:t>Track evidence metadata without using GCCS as a CUI repository.</a:t>
+              <a:t>Track evidence metadata without using </a:t>
+            </a:r>
+            <a:r>
+              <a:t>FeDril</a:t>
+            </a:r>
+            <a:r>
+              <a:t> as a CUI repository.</a:t>
             </a:r>
           </a:p>
           <a:p xmlns:a="http://schemas.openxmlformats.org/drawingml/2006/main">
@@ -7067,7 +6996,10 @@
               </a:defRPr>
             </a:pPr>
             <a:r>
-              <a:t>GCCS | No-CUI compliance management only</a:t>
+              <a:t>FeDril</a:t>
+            </a:r>
+            <a:r>
+              <a:t> | No-CUI compliance management only</a:t>
             </a:r>
           </a:p>
         </p:txBody>
@@ -8549,7 +8481,10 @@
               </a:defRPr>
             </a:pPr>
             <a:r>
-              <a:t>GCCS | No-CUI compliance management only</a:t>
+              <a:t>FeDril</a:t>
+            </a:r>
+            <a:r>
+              <a:t> | No-CUI compliance management only</a:t>
             </a:r>
           </a:p>
         </p:txBody>
@@ -9431,7 +9366,10 @@
               </a:defRPr>
             </a:pPr>
             <a:r>
-              <a:t>GCCS | No-CUI compliance management only</a:t>
+              <a:t>FeDril</a:t>
+            </a:r>
+            <a:r>
+              <a:t> | No-CUI compliance management only</a:t>
             </a:r>
           </a:p>
         </p:txBody>
@@ -9944,7 +9882,10 @@
               </a:defRPr>
             </a:pPr>
             <a:r>
-              <a:t>GCCS | No-CUI compliance management only</a:t>
+              <a:t>FeDril</a:t>
+            </a:r>
+            <a:r>
+              <a:t> | No-CUI compliance management only</a:t>
             </a:r>
           </a:p>
         </p:txBody>
@@ -10656,7 +10597,10 @@
               </a:defRPr>
             </a:pPr>
             <a:r>
-              <a:t>GCCS | No-CUI compliance management only</a:t>
+              <a:t>FeDril</a:t>
+            </a:r>
+            <a:r>
+              <a:t> | No-CUI compliance management only</a:t>
             </a:r>
           </a:p>
         </p:txBody>
@@ -11228,7 +11172,10 @@
               </a:defRPr>
             </a:pPr>
             <a:r>
-              <a:t>GCCS | No-CUI compliance management only</a:t>
+              <a:t>FeDril</a:t>
+            </a:r>
+            <a:r>
+              <a:t> | No-CUI compliance management only</a:t>
             </a:r>
           </a:p>
         </p:txBody>

</xml_diff>